<commit_message>
fix: p6 case 2 -> Payment Concentration (canonical), body 15pt, shorter rows
- spec-executive-capability.json: second case renamed to Payment Concentration; mechanism now matches portfolio canonical 'per-currency auditable, deterministic rolling 7-day payment-commitment exposure calculation'; keeps 51/51 TESTED and prototype/adoption-not-proven boundary; all three table rows shortened
- make-pptx.mjs: table body raised to 15pt (>=14pt requirement), header 11pt, adaptive row heights with safe padding
- re-rendered PPTX + PDF; QA: 9 pages, 0 out-of-bounds, p6 body/footer no collision
</commit_message>
<xml_diff>
--- a/Paul-Tradecraft-Executive-Capability-Deck.pptx
+++ b/Paul-Tradecraft-Executive-Capability-Deck.pptx
@@ -950,7 +950,7 @@
           <a:p>
             <a:r>
               <a:rPr lang="en-US" dirty="0"/>
-              <a:t>狀態紀律：TESTED = 可重跑驗證通過；PENDING = 合成資料先行，adoption-ROI 尚未實證。</a:t>
+              <a:t>狀態紀律：TESTED = 可重跑驗證通過；PENDING = 合成資料先行。Payment Concentration 為 prototype evidence：優於 Excel、商業採用、支付意願尚未實證。</a:t>
             </a:r>
             <a:endParaRPr lang="en-US" dirty="0"/>
           </a:p>
@@ -4930,8 +4930,8 @@
         </p:nvSpPr>
         <p:spPr>
           <a:xfrm>
-            <a:off x="704088" y="2148840"/>
-            <a:ext cx="2530602" cy="384048"/>
+            <a:off x="731520" y="2148840"/>
+            <a:ext cx="2475738" cy="384048"/>
           </a:xfrm>
           <a:prstGeom prst="rect">
             <a:avLst/>
@@ -4947,7 +4947,7 @@
               <a:buNone/>
             </a:pPr>
             <a:r>
-              <a:rPr lang="en-US" sz="950" b="1" spc="150" kern="0" dirty="0">
+              <a:rPr lang="en-US" sz="1100" b="1" spc="150" kern="0" dirty="0">
                 <a:solidFill>
                   <a:srgbClr val="1D4ED8"/>
                 </a:solidFill>
@@ -4957,7 +4957,7 @@
               </a:rPr>
               <a:t>CASE</a:t>
             </a:r>
-            <a:endParaRPr lang="en-US" sz="950" dirty="0"/>
+            <a:endParaRPr lang="en-US" sz="1100" dirty="0"/>
           </a:p>
         </p:txBody>
       </p:sp>
@@ -4969,8 +4969,8 @@
         </p:nvSpPr>
         <p:spPr>
           <a:xfrm>
-            <a:off x="3454146" y="2148840"/>
-            <a:ext cx="2530602" cy="384048"/>
+            <a:off x="3481578" y="2148840"/>
+            <a:ext cx="2475738" cy="384048"/>
           </a:xfrm>
           <a:prstGeom prst="rect">
             <a:avLst/>
@@ -4986,7 +4986,7 @@
               <a:buNone/>
             </a:pPr>
             <a:r>
-              <a:rPr lang="en-US" sz="950" b="1" spc="150" kern="0" dirty="0">
+              <a:rPr lang="en-US" sz="1100" b="1" spc="150" kern="0" dirty="0">
                 <a:solidFill>
                   <a:srgbClr val="1D4ED8"/>
                 </a:solidFill>
@@ -4996,7 +4996,7 @@
               </a:rPr>
               <a:t>CORE MECHANISM</a:t>
             </a:r>
-            <a:endParaRPr lang="en-US" sz="950" dirty="0"/>
+            <a:endParaRPr lang="en-US" sz="1100" dirty="0"/>
           </a:p>
         </p:txBody>
       </p:sp>
@@ -5008,8 +5008,8 @@
         </p:nvSpPr>
         <p:spPr>
           <a:xfrm>
-            <a:off x="6204204" y="2148840"/>
-            <a:ext cx="2530602" cy="384048"/>
+            <a:off x="6231636" y="2148840"/>
+            <a:ext cx="2475738" cy="384048"/>
           </a:xfrm>
           <a:prstGeom prst="rect">
             <a:avLst/>
@@ -5025,7 +5025,7 @@
               <a:buNone/>
             </a:pPr>
             <a:r>
-              <a:rPr lang="en-US" sz="950" b="1" spc="150" kern="0" dirty="0">
+              <a:rPr lang="en-US" sz="1100" b="1" spc="150" kern="0" dirty="0">
                 <a:solidFill>
                   <a:srgbClr val="1D4ED8"/>
                 </a:solidFill>
@@ -5035,7 +5035,7 @@
               </a:rPr>
               <a:t>EVIDENCE</a:t>
             </a:r>
-            <a:endParaRPr lang="en-US" sz="950" dirty="0"/>
+            <a:endParaRPr lang="en-US" sz="1100" dirty="0"/>
           </a:p>
         </p:txBody>
       </p:sp>
@@ -5047,8 +5047,8 @@
         </p:nvSpPr>
         <p:spPr>
           <a:xfrm>
-            <a:off x="8954262" y="2148840"/>
-            <a:ext cx="2530602" cy="384048"/>
+            <a:off x="8981694" y="2148840"/>
+            <a:ext cx="2475738" cy="384048"/>
           </a:xfrm>
           <a:prstGeom prst="rect">
             <a:avLst/>
@@ -5064,7 +5064,7 @@
               <a:buNone/>
             </a:pPr>
             <a:r>
-              <a:rPr lang="en-US" sz="950" b="1" spc="150" kern="0" dirty="0">
+              <a:rPr lang="en-US" sz="1100" b="1" spc="150" kern="0" dirty="0">
                 <a:solidFill>
                   <a:srgbClr val="1D4ED8"/>
                 </a:solidFill>
@@ -5074,7 +5074,7 @@
               </a:rPr>
               <a:t>STATUS</a:t>
             </a:r>
-            <a:endParaRPr lang="en-US" sz="950" dirty="0"/>
+            <a:endParaRPr lang="en-US" sz="1100" dirty="0"/>
           </a:p>
         </p:txBody>
       </p:sp>
@@ -5106,8 +5106,8 @@
         </p:nvSpPr>
         <p:spPr>
           <a:xfrm>
-            <a:off x="704088" y="2697480"/>
-            <a:ext cx="2530602" cy="548640"/>
+            <a:off x="731520" y="2715768"/>
+            <a:ext cx="2475738" cy="731520"/>
           </a:xfrm>
           <a:prstGeom prst="rect">
             <a:avLst/>
@@ -5121,12 +5121,12 @@
           <a:p>
             <a:pPr indent="0" marL="0">
               <a:lnSpc>
-                <a:spcPct val="112000"/>
+                <a:spcPct val="120000"/>
               </a:lnSpc>
               <a:buNone/>
             </a:pPr>
             <a:r>
-              <a:rPr lang="en-US" sz="1100" dirty="0">
+              <a:rPr lang="en-US" sz="1500" dirty="0">
                 <a:solidFill>
                   <a:srgbClr val="0B1B33"/>
                 </a:solidFill>
@@ -5136,7 +5136,7 @@
               </a:rPr>
               <a:t>AI Trade Deal Desk</a:t>
             </a:r>
-            <a:endParaRPr lang="en-US" sz="1100" dirty="0"/>
+            <a:endParaRPr lang="en-US" sz="1500" dirty="0"/>
           </a:p>
         </p:txBody>
       </p:sp>
@@ -5148,8 +5148,8 @@
         </p:nvSpPr>
         <p:spPr>
           <a:xfrm>
-            <a:off x="3454146" y="2697480"/>
-            <a:ext cx="2530602" cy="548640"/>
+            <a:off x="3481578" y="2715768"/>
+            <a:ext cx="2475738" cy="731520"/>
           </a:xfrm>
           <a:prstGeom prst="rect">
             <a:avLst/>
@@ -5163,12 +5163,12 @@
           <a:p>
             <a:pPr indent="0" marL="0">
               <a:lnSpc>
-                <a:spcPct val="112000"/>
+                <a:spcPct val="120000"/>
               </a:lnSpc>
               <a:buNone/>
             </a:pPr>
             <a:r>
-              <a:rPr lang="en-US" sz="1100" dirty="0">
+              <a:rPr lang="en-US" sz="1500" dirty="0">
                 <a:solidFill>
                   <a:srgbClr val="0B1B33"/>
                 </a:solidFill>
@@ -5176,9 +5176,9 @@
                 <a:ea typeface="Microsoft JhengHei" pitchFamily="34" charset="-122"/>
                 <a:cs typeface="Microsoft JhengHei" pitchFamily="34" charset="-120"/>
               </a:rPr>
-              <a:t>報價與匯率決策工作流</a:t>
-            </a:r>
-            <a:endParaRPr lang="en-US" sz="1100" dirty="0"/>
+              <a:t>報價/匯率決策工作流</a:t>
+            </a:r>
+            <a:endParaRPr lang="en-US" sz="1500" dirty="0"/>
           </a:p>
         </p:txBody>
       </p:sp>
@@ -5190,8 +5190,8 @@
         </p:nvSpPr>
         <p:spPr>
           <a:xfrm>
-            <a:off x="6204204" y="2697480"/>
-            <a:ext cx="2530602" cy="548640"/>
+            <a:off x="6231636" y="2715768"/>
+            <a:ext cx="2475738" cy="731520"/>
           </a:xfrm>
           <a:prstGeom prst="rect">
             <a:avLst/>
@@ -5205,12 +5205,12 @@
           <a:p>
             <a:pPr indent="0" marL="0">
               <a:lnSpc>
-                <a:spcPct val="112000"/>
+                <a:spcPct val="120000"/>
               </a:lnSpc>
               <a:buNone/>
             </a:pPr>
             <a:r>
-              <a:rPr lang="en-US" sz="1100" dirty="0">
+              <a:rPr lang="en-US" sz="1500" dirty="0">
                 <a:solidFill>
                   <a:srgbClr val="0B1B33"/>
                 </a:solidFill>
@@ -5218,9 +5218,9 @@
                 <a:ea typeface="Microsoft JhengHei" pitchFamily="34" charset="-122"/>
                 <a:cs typeface="Microsoft JhengHei" pitchFamily="34" charset="-120"/>
               </a:rPr>
-              <a:t>13/13 情境 + 5/5 邊界驗證通過</a:t>
-            </a:r>
-            <a:endParaRPr lang="en-US" sz="1100" dirty="0"/>
+              <a:t>13/13 + 5/5 驗證通過</a:t>
+            </a:r>
+            <a:endParaRPr lang="en-US" sz="1500" dirty="0"/>
           </a:p>
         </p:txBody>
       </p:sp>
@@ -5232,8 +5232,8 @@
         </p:nvSpPr>
         <p:spPr>
           <a:xfrm>
-            <a:off x="8954262" y="2697480"/>
-            <a:ext cx="2530602" cy="548640"/>
+            <a:off x="8981694" y="2715768"/>
+            <a:ext cx="2475738" cy="731520"/>
           </a:xfrm>
           <a:prstGeom prst="rect">
             <a:avLst/>
@@ -5247,12 +5247,12 @@
           <a:p>
             <a:pPr indent="0" marL="0">
               <a:lnSpc>
-                <a:spcPct val="112000"/>
+                <a:spcPct val="120000"/>
               </a:lnSpc>
               <a:buNone/>
             </a:pPr>
             <a:r>
-              <a:rPr lang="en-US" sz="1100" b="1" dirty="0">
+              <a:rPr lang="en-US" sz="1500" b="1" dirty="0">
                 <a:solidFill>
                   <a:srgbClr val="1D4ED8"/>
                 </a:solidFill>
@@ -5262,7 +5262,7 @@
               </a:rPr>
               <a:t>TESTED</a:t>
             </a:r>
-            <a:endParaRPr lang="en-US" sz="1100" dirty="0"/>
+            <a:endParaRPr lang="en-US" sz="1500" dirty="0"/>
           </a:p>
         </p:txBody>
       </p:sp>
@@ -5294,8 +5294,8 @@
         </p:nvSpPr>
         <p:spPr>
           <a:xfrm>
-            <a:off x="704088" y="3355848"/>
-            <a:ext cx="2530602" cy="548640"/>
+            <a:off x="731520" y="3355848"/>
+            <a:ext cx="2475738" cy="1432560"/>
           </a:xfrm>
           <a:prstGeom prst="rect">
             <a:avLst/>
@@ -5309,12 +5309,12 @@
           <a:p>
             <a:pPr indent="0" marL="0">
               <a:lnSpc>
-                <a:spcPct val="112000"/>
+                <a:spcPct val="120000"/>
               </a:lnSpc>
               <a:buNone/>
             </a:pPr>
             <a:r>
-              <a:rPr lang="en-US" sz="1100" dirty="0">
+              <a:rPr lang="en-US" sz="1500" dirty="0">
                 <a:solidFill>
                   <a:srgbClr val="0B1B33"/>
                 </a:solidFill>
@@ -5322,9 +5322,9 @@
                 <a:ea typeface="Segoe UI" pitchFamily="34" charset="-122"/>
                 <a:cs typeface="Segoe UI" pitchFamily="34" charset="-120"/>
               </a:rPr>
-              <a:t>AI Payment Advisor</a:t>
-            </a:r>
-            <a:endParaRPr lang="en-US" sz="1100" dirty="0"/>
+              <a:t>Payment Concentration</a:t>
+            </a:r>
+            <a:endParaRPr lang="en-US" sz="1500" dirty="0"/>
           </a:p>
         </p:txBody>
       </p:sp>
@@ -5336,8 +5336,8 @@
         </p:nvSpPr>
         <p:spPr>
           <a:xfrm>
-            <a:off x="3454146" y="3355848"/>
-            <a:ext cx="2530602" cy="548640"/>
+            <a:off x="3481578" y="3355848"/>
+            <a:ext cx="2475738" cy="1432560"/>
           </a:xfrm>
           <a:prstGeom prst="rect">
             <a:avLst/>
@@ -5351,12 +5351,12 @@
           <a:p>
             <a:pPr indent="0" marL="0">
               <a:lnSpc>
-                <a:spcPct val="112000"/>
+                <a:spcPct val="120000"/>
               </a:lnSpc>
               <a:buNone/>
             </a:pPr>
             <a:r>
-              <a:rPr lang="en-US" sz="1100" dirty="0">
+              <a:rPr lang="en-US" sz="1500" dirty="0">
                 <a:solidFill>
                   <a:srgbClr val="0B1B33"/>
                 </a:solidFill>
@@ -5364,9 +5364,9 @@
                 <a:ea typeface="Microsoft JhengHei" pitchFamily="34" charset="-122"/>
                 <a:cs typeface="Microsoft JhengHei" pitchFamily="34" charset="-120"/>
               </a:rPr>
-              <a:t>信用狀與付款條件決策</a:t>
-            </a:r>
-            <a:endParaRPr lang="en-US" sz="1100" dirty="0"/>
+              <a:t>按幣別的可稽核、確定性 rolling 7-day payment-commitment exposure calculation</a:t>
+            </a:r>
+            <a:endParaRPr lang="en-US" sz="1500" dirty="0"/>
           </a:p>
         </p:txBody>
       </p:sp>
@@ -5378,8 +5378,8 @@
         </p:nvSpPr>
         <p:spPr>
           <a:xfrm>
-            <a:off x="6204204" y="3355848"/>
-            <a:ext cx="2530602" cy="548640"/>
+            <a:off x="6231636" y="3355848"/>
+            <a:ext cx="2475738" cy="1432560"/>
           </a:xfrm>
           <a:prstGeom prst="rect">
             <a:avLst/>
@@ -5393,12 +5393,12 @@
           <a:p>
             <a:pPr indent="0" marL="0">
               <a:lnSpc>
-                <a:spcPct val="112000"/>
+                <a:spcPct val="120000"/>
               </a:lnSpc>
               <a:buNone/>
             </a:pPr>
             <a:r>
-              <a:rPr lang="en-US" sz="1100" dirty="0">
+              <a:rPr lang="en-US" sz="1500" dirty="0">
                 <a:solidFill>
                   <a:srgbClr val="0B1B33"/>
                 </a:solidFill>
@@ -5406,9 +5406,9 @@
                 <a:ea typeface="Microsoft JhengHei" pitchFamily="34" charset="-122"/>
                 <a:cs typeface="Microsoft JhengHei" pitchFamily="34" charset="-120"/>
               </a:rPr>
-              <a:t>51/51 驗證案例通過</a:t>
-            </a:r>
-            <a:endParaRPr lang="en-US" sz="1100" dirty="0"/>
+              <a:t>51/51 驗證通過（prototype）</a:t>
+            </a:r>
+            <a:endParaRPr lang="en-US" sz="1500" dirty="0"/>
           </a:p>
         </p:txBody>
       </p:sp>
@@ -5420,8 +5420,8 @@
         </p:nvSpPr>
         <p:spPr>
           <a:xfrm>
-            <a:off x="8954262" y="3355848"/>
-            <a:ext cx="2530602" cy="548640"/>
+            <a:off x="8981694" y="3355848"/>
+            <a:ext cx="2475738" cy="1432560"/>
           </a:xfrm>
           <a:prstGeom prst="rect">
             <a:avLst/>
@@ -5435,12 +5435,12 @@
           <a:p>
             <a:pPr indent="0" marL="0">
               <a:lnSpc>
-                <a:spcPct val="112000"/>
+                <a:spcPct val="120000"/>
               </a:lnSpc>
               <a:buNone/>
             </a:pPr>
             <a:r>
-              <a:rPr lang="en-US" sz="1100" b="1" dirty="0">
+              <a:rPr lang="en-US" sz="1500" b="1" dirty="0">
                 <a:solidFill>
                   <a:srgbClr val="1D4ED8"/>
                 </a:solidFill>
@@ -5450,7 +5450,7 @@
               </a:rPr>
               <a:t>TESTED</a:t>
             </a:r>
-            <a:endParaRPr lang="en-US" sz="1100" dirty="0"/>
+            <a:endParaRPr lang="en-US" sz="1500" dirty="0"/>
           </a:p>
         </p:txBody>
       </p:sp>
@@ -5462,7 +5462,7 @@
         </p:nvSpPr>
         <p:spPr>
           <a:xfrm>
-            <a:off x="594360" y="3977640"/>
+            <a:off x="594360" y="4660392"/>
             <a:ext cx="11000232" cy="7315"/>
           </a:xfrm>
           <a:prstGeom prst="rect">
@@ -5482,8 +5482,8 @@
         </p:nvSpPr>
         <p:spPr>
           <a:xfrm>
-            <a:off x="704088" y="4014216"/>
-            <a:ext cx="2530602" cy="548640"/>
+            <a:off x="731520" y="4696968"/>
+            <a:ext cx="2475738" cy="899160"/>
           </a:xfrm>
           <a:prstGeom prst="rect">
             <a:avLst/>
@@ -5497,12 +5497,12 @@
           <a:p>
             <a:pPr indent="0" marL="0">
               <a:lnSpc>
-                <a:spcPct val="112000"/>
+                <a:spcPct val="120000"/>
               </a:lnSpc>
               <a:buNone/>
             </a:pPr>
             <a:r>
-              <a:rPr lang="en-US" sz="1100" dirty="0">
+              <a:rPr lang="en-US" sz="1500" dirty="0">
                 <a:solidFill>
                   <a:srgbClr val="0B1B33"/>
                 </a:solidFill>
@@ -5512,7 +5512,7 @@
               </a:rPr>
               <a:t>Commercial Decision Desk</a:t>
             </a:r>
-            <a:endParaRPr lang="en-US" sz="1100" dirty="0"/>
+            <a:endParaRPr lang="en-US" sz="1500" dirty="0"/>
           </a:p>
         </p:txBody>
       </p:sp>
@@ -5524,8 +5524,8 @@
         </p:nvSpPr>
         <p:spPr>
           <a:xfrm>
-            <a:off x="3454146" y="4014216"/>
-            <a:ext cx="2530602" cy="548640"/>
+            <a:off x="3481578" y="4696968"/>
+            <a:ext cx="2475738" cy="899160"/>
           </a:xfrm>
           <a:prstGeom prst="rect">
             <a:avLst/>
@@ -5539,12 +5539,12 @@
           <a:p>
             <a:pPr indent="0" marL="0">
               <a:lnSpc>
-                <a:spcPct val="112000"/>
+                <a:spcPct val="120000"/>
               </a:lnSpc>
               <a:buNone/>
             </a:pPr>
             <a:r>
-              <a:rPr lang="en-US" sz="1100" dirty="0">
+              <a:rPr lang="en-US" sz="1500" dirty="0">
                 <a:solidFill>
                   <a:srgbClr val="0B1B33"/>
                 </a:solidFill>
@@ -5554,7 +5554,7 @@
               </a:rPr>
               <a:t>跨案決策看板 · 8 條硬規則</a:t>
             </a:r>
-            <a:endParaRPr lang="en-US" sz="1100" dirty="0"/>
+            <a:endParaRPr lang="en-US" sz="1500" dirty="0"/>
           </a:p>
         </p:txBody>
       </p:sp>
@@ -5566,8 +5566,8 @@
         </p:nvSpPr>
         <p:spPr>
           <a:xfrm>
-            <a:off x="6204204" y="4014216"/>
-            <a:ext cx="2530602" cy="548640"/>
+            <a:off x="6231636" y="4696968"/>
+            <a:ext cx="2475738" cy="899160"/>
           </a:xfrm>
           <a:prstGeom prst="rect">
             <a:avLst/>
@@ -5581,12 +5581,12 @@
           <a:p>
             <a:pPr indent="0" marL="0">
               <a:lnSpc>
-                <a:spcPct val="112000"/>
+                <a:spcPct val="120000"/>
               </a:lnSpc>
               <a:buNone/>
             </a:pPr>
             <a:r>
-              <a:rPr lang="en-US" sz="1100" dirty="0">
+              <a:rPr lang="en-US" sz="1500" dirty="0">
                 <a:solidFill>
                   <a:srgbClr val="0B1B33"/>
                 </a:solidFill>
@@ -5594,9 +5594,9 @@
                 <a:ea typeface="Microsoft JhengHei" pitchFamily="34" charset="-122"/>
                 <a:cs typeface="Microsoft JhengHei" pitchFamily="34" charset="-120"/>
               </a:rPr>
-              <a:t>38/38 合成案例（fixture）</a:t>
-            </a:r>
-            <a:endParaRPr lang="en-US" sz="1100" dirty="0"/>
+              <a:t>38/38 合成案例</a:t>
+            </a:r>
+            <a:endParaRPr lang="en-US" sz="1500" dirty="0"/>
           </a:p>
         </p:txBody>
       </p:sp>
@@ -5608,8 +5608,8 @@
         </p:nvSpPr>
         <p:spPr>
           <a:xfrm>
-            <a:off x="8954262" y="4014216"/>
-            <a:ext cx="2530602" cy="548640"/>
+            <a:off x="8981694" y="4696968"/>
+            <a:ext cx="2475738" cy="899160"/>
           </a:xfrm>
           <a:prstGeom prst="rect">
             <a:avLst/>
@@ -5623,12 +5623,12 @@
           <a:p>
             <a:pPr indent="0" marL="0">
               <a:lnSpc>
-                <a:spcPct val="112000"/>
+                <a:spcPct val="120000"/>
               </a:lnSpc>
               <a:buNone/>
             </a:pPr>
             <a:r>
-              <a:rPr lang="en-US" sz="1100" b="1" dirty="0">
+              <a:rPr lang="en-US" sz="1500" b="1" dirty="0">
                 <a:solidFill>
                   <a:srgbClr val="1D4ED8"/>
                 </a:solidFill>
@@ -5638,7 +5638,7 @@
               </a:rPr>
               <a:t>PENDING</a:t>
             </a:r>
-            <a:endParaRPr lang="en-US" sz="1100" dirty="0"/>
+            <a:endParaRPr lang="en-US" sz="1500" dirty="0"/>
           </a:p>
         </p:txBody>
       </p:sp>

</xml_diff>

<commit_message>
fix: visible claim boundary in p6 evidence table
- Payment Concentration evidence cell: '51/51 驗證通過（prototype）' + 11.5pt muted-gray sub-note 'Not evidence of adoption or ROI.'
- CDD evidence cell: '38/38 合成案例（synthetic proof）'
- layoutTable supports [main, note] cells; body stays 15pt; other pages/cases/numbers/statuses untouched
- QA: 9 pages 0 out-of-bounds, p6 body/footer gap 64.5pt, no main/note overlap
</commit_message>
<xml_diff>
--- a/Paul-Tradecraft-Executive-Capability-Deck.pptx
+++ b/Paul-Tradecraft-Executive-Capability-Deck.pptx
@@ -5295,7 +5295,7 @@
         <p:spPr>
           <a:xfrm>
             <a:off x="731520" y="3355848"/>
-            <a:ext cx="2475738" cy="1432560"/>
+            <a:ext cx="2475738" cy="1863471"/>
           </a:xfrm>
           <a:prstGeom prst="rect">
             <a:avLst/>
@@ -5337,7 +5337,7 @@
         <p:spPr>
           <a:xfrm>
             <a:off x="3481578" y="3355848"/>
-            <a:ext cx="2475738" cy="1432560"/>
+            <a:ext cx="2475738" cy="1863471"/>
           </a:xfrm>
           <a:prstGeom prst="rect">
             <a:avLst/>
@@ -5378,17 +5378,17 @@
         </p:nvSpPr>
         <p:spPr>
           <a:xfrm>
-            <a:off x="6231636" y="3355848"/>
-            <a:ext cx="2475738" cy="1432560"/>
-          </a:xfrm>
-          <a:prstGeom prst="rect">
-            <a:avLst/>
-          </a:prstGeom>
-          <a:noFill/>
-          <a:ln/>
-        </p:spPr>
-        <p:txBody>
-          <a:bodyPr wrap="square" rtlCol="0" anchor="ctr"/>
+            <a:off x="6231636" y="3374136"/>
+            <a:ext cx="2475738" cy="533400"/>
+          </a:xfrm>
+          <a:prstGeom prst="rect">
+            <a:avLst/>
+          </a:prstGeom>
+          <a:noFill/>
+          <a:ln/>
+        </p:spPr>
+        <p:txBody>
+          <a:bodyPr wrap="square" rtlCol="0" anchor="t"/>
           <a:lstStyle/>
           <a:p>
             <a:pPr indent="0" marL="0">
@@ -5420,17 +5420,17 @@
         </p:nvSpPr>
         <p:spPr>
           <a:xfrm>
-            <a:off x="8981694" y="3355848"/>
-            <a:ext cx="2475738" cy="1432560"/>
-          </a:xfrm>
-          <a:prstGeom prst="rect">
-            <a:avLst/>
-          </a:prstGeom>
-          <a:noFill/>
-          <a:ln/>
-        </p:spPr>
-        <p:txBody>
-          <a:bodyPr wrap="square" rtlCol="0" anchor="ctr"/>
+            <a:off x="6231636" y="3944112"/>
+            <a:ext cx="2475738" cy="1147191"/>
+          </a:xfrm>
+          <a:prstGeom prst="rect">
+            <a:avLst/>
+          </a:prstGeom>
+          <a:noFill/>
+          <a:ln/>
+        </p:spPr>
+        <p:txBody>
+          <a:bodyPr wrap="square" rtlCol="0" anchor="t"/>
           <a:lstStyle/>
           <a:p>
             <a:pPr indent="0" marL="0">
@@ -5440,50 +5440,30 @@
               <a:buNone/>
             </a:pPr>
             <a:r>
-              <a:rPr lang="en-US" sz="1500" b="1" dirty="0">
-                <a:solidFill>
-                  <a:srgbClr val="1D4ED8"/>
+              <a:rPr lang="en-US" sz="1150" dirty="0">
+                <a:solidFill>
+                  <a:srgbClr val="8A97A8"/>
                 </a:solidFill>
                 <a:latin typeface="Segoe UI" pitchFamily="34" charset="0"/>
                 <a:ea typeface="Segoe UI" pitchFamily="34" charset="-122"/>
                 <a:cs typeface="Segoe UI" pitchFamily="34" charset="-120"/>
               </a:rPr>
-              <a:t>TESTED</a:t>
-            </a:r>
-            <a:endParaRPr lang="en-US" sz="1500" dirty="0"/>
-          </a:p>
-        </p:txBody>
-      </p:sp>
-      <p:sp>
-        <p:nvSpPr>
-          <p:cNvPr id="20" name="Shape 18"/>
-          <p:cNvSpPr/>
-          <p:nvPr/>
-        </p:nvSpPr>
-        <p:spPr>
-          <a:xfrm>
-            <a:off x="594360" y="4660392"/>
-            <a:ext cx="11000232" cy="7315"/>
-          </a:xfrm>
-          <a:prstGeom prst="rect">
-            <a:avLst/>
-          </a:prstGeom>
-          <a:solidFill>
-            <a:srgbClr val="E2E8F0"/>
-          </a:solidFill>
-          <a:ln/>
-        </p:spPr>
-      </p:sp>
-      <p:sp>
-        <p:nvSpPr>
-          <p:cNvPr id="21" name="Text 19"/>
-          <p:cNvSpPr/>
-          <p:nvPr/>
-        </p:nvSpPr>
-        <p:spPr>
-          <a:xfrm>
-            <a:off x="731520" y="4696968"/>
-            <a:ext cx="2475738" cy="899160"/>
+              <a:t>Not evidence of adoption or ROI.</a:t>
+            </a:r>
+            <a:endParaRPr lang="en-US" sz="1150" dirty="0"/>
+          </a:p>
+        </p:txBody>
+      </p:sp>
+      <p:sp>
+        <p:nvSpPr>
+          <p:cNvPr id="20" name="Text 18"/>
+          <p:cNvSpPr/>
+          <p:nvPr/>
+        </p:nvSpPr>
+        <p:spPr>
+          <a:xfrm>
+            <a:off x="8981694" y="3355848"/>
+            <a:ext cx="2475738" cy="1863471"/>
           </a:xfrm>
           <a:prstGeom prst="rect">
             <a:avLst/>
@@ -5502,15 +5482,15 @@
               <a:buNone/>
             </a:pPr>
             <a:r>
-              <a:rPr lang="en-US" sz="1500" dirty="0">
-                <a:solidFill>
-                  <a:srgbClr val="0B1B33"/>
+              <a:rPr lang="en-US" sz="1500" b="1" dirty="0">
+                <a:solidFill>
+                  <a:srgbClr val="1D4ED8"/>
                 </a:solidFill>
                 <a:latin typeface="Segoe UI" pitchFamily="34" charset="0"/>
                 <a:ea typeface="Segoe UI" pitchFamily="34" charset="-122"/>
                 <a:cs typeface="Segoe UI" pitchFamily="34" charset="-120"/>
               </a:rPr>
-              <a:t>Commercial Decision Desk</a:t>
+              <a:t>TESTED</a:t>
             </a:r>
             <a:endParaRPr lang="en-US" sz="1500" dirty="0"/>
           </a:p>
@@ -5518,14 +5498,34 @@
       </p:sp>
       <p:sp>
         <p:nvSpPr>
+          <p:cNvPr id="21" name="Shape 19"/>
+          <p:cNvSpPr/>
+          <p:nvPr/>
+        </p:nvSpPr>
+        <p:spPr>
+          <a:xfrm>
+            <a:off x="594360" y="5091303"/>
+            <a:ext cx="11000232" cy="7315"/>
+          </a:xfrm>
+          <a:prstGeom prst="rect">
+            <a:avLst/>
+          </a:prstGeom>
+          <a:solidFill>
+            <a:srgbClr val="E2E8F0"/>
+          </a:solidFill>
+          <a:ln/>
+        </p:spPr>
+      </p:sp>
+      <p:sp>
+        <p:nvSpPr>
           <p:cNvPr id="22" name="Text 20"/>
           <p:cNvSpPr/>
           <p:nvPr/>
         </p:nvSpPr>
         <p:spPr>
           <a:xfrm>
-            <a:off x="3481578" y="4696968"/>
-            <a:ext cx="2475738" cy="899160"/>
+            <a:off x="731520" y="5127879"/>
+            <a:ext cx="2475738" cy="935736"/>
           </a:xfrm>
           <a:prstGeom prst="rect">
             <a:avLst/>
@@ -5548,11 +5548,11 @@
                 <a:solidFill>
                   <a:srgbClr val="0B1B33"/>
                 </a:solidFill>
-                <a:latin typeface="Microsoft JhengHei" pitchFamily="34" charset="0"/>
-                <a:ea typeface="Microsoft JhengHei" pitchFamily="34" charset="-122"/>
-                <a:cs typeface="Microsoft JhengHei" pitchFamily="34" charset="-120"/>
-              </a:rPr>
-              <a:t>跨案決策看板 · 8 條硬規則</a:t>
+                <a:latin typeface="Segoe UI" pitchFamily="34" charset="0"/>
+                <a:ea typeface="Segoe UI" pitchFamily="34" charset="-122"/>
+                <a:cs typeface="Segoe UI" pitchFamily="34" charset="-120"/>
+              </a:rPr>
+              <a:t>Commercial Decision Desk</a:t>
             </a:r>
             <a:endParaRPr lang="en-US" sz="1500" dirty="0"/>
           </a:p>
@@ -5566,8 +5566,8 @@
         </p:nvSpPr>
         <p:spPr>
           <a:xfrm>
-            <a:off x="6231636" y="4696968"/>
-            <a:ext cx="2475738" cy="899160"/>
+            <a:off x="3481578" y="5127879"/>
+            <a:ext cx="2475738" cy="935736"/>
           </a:xfrm>
           <a:prstGeom prst="rect">
             <a:avLst/>
@@ -5594,7 +5594,7 @@
                 <a:ea typeface="Microsoft JhengHei" pitchFamily="34" charset="-122"/>
                 <a:cs typeface="Microsoft JhengHei" pitchFamily="34" charset="-120"/>
               </a:rPr>
-              <a:t>38/38 合成案例</a:t>
+              <a:t>跨案決策看板 · 8 條硬規則</a:t>
             </a:r>
             <a:endParaRPr lang="en-US" sz="1500" dirty="0"/>
           </a:p>
@@ -5608,8 +5608,8 @@
         </p:nvSpPr>
         <p:spPr>
           <a:xfrm>
-            <a:off x="8981694" y="4696968"/>
-            <a:ext cx="2475738" cy="899160"/>
+            <a:off x="6231636" y="5127879"/>
+            <a:ext cx="2475738" cy="935736"/>
           </a:xfrm>
           <a:prstGeom prst="rect">
             <a:avLst/>
@@ -5628,6 +5628,48 @@
               <a:buNone/>
             </a:pPr>
             <a:r>
+              <a:rPr lang="en-US" sz="1500" dirty="0">
+                <a:solidFill>
+                  <a:srgbClr val="0B1B33"/>
+                </a:solidFill>
+                <a:latin typeface="Microsoft JhengHei" pitchFamily="34" charset="0"/>
+                <a:ea typeface="Microsoft JhengHei" pitchFamily="34" charset="-122"/>
+                <a:cs typeface="Microsoft JhengHei" pitchFamily="34" charset="-120"/>
+              </a:rPr>
+              <a:t>38/38 合成案例（synthetic proof）</a:t>
+            </a:r>
+            <a:endParaRPr lang="en-US" sz="1500" dirty="0"/>
+          </a:p>
+        </p:txBody>
+      </p:sp>
+      <p:sp>
+        <p:nvSpPr>
+          <p:cNvPr id="25" name="Text 23"/>
+          <p:cNvSpPr/>
+          <p:nvPr/>
+        </p:nvSpPr>
+        <p:spPr>
+          <a:xfrm>
+            <a:off x="8981694" y="5127879"/>
+            <a:ext cx="2475738" cy="935736"/>
+          </a:xfrm>
+          <a:prstGeom prst="rect">
+            <a:avLst/>
+          </a:prstGeom>
+          <a:noFill/>
+          <a:ln/>
+        </p:spPr>
+        <p:txBody>
+          <a:bodyPr wrap="square" rtlCol="0" anchor="ctr"/>
+          <a:lstStyle/>
+          <a:p>
+            <a:pPr indent="0" marL="0">
+              <a:lnSpc>
+                <a:spcPct val="120000"/>
+              </a:lnSpc>
+              <a:buNone/>
+            </a:pPr>
+            <a:r>
               <a:rPr lang="en-US" sz="1500" b="1" dirty="0">
                 <a:solidFill>
                   <a:srgbClr val="1D4ED8"/>
@@ -5644,7 +5686,7 @@
       </p:sp>
       <p:sp>
         <p:nvSpPr>
-          <p:cNvPr id="25" name="Shape 23"/>
+          <p:cNvPr id="26" name="Shape 24"/>
           <p:cNvSpPr/>
           <p:nvPr/>
         </p:nvSpPr>
@@ -5664,7 +5706,7 @@
       </p:sp>
       <p:sp>
         <p:nvSpPr>
-          <p:cNvPr id="26" name="Shape 24"/>
+          <p:cNvPr id="27" name="Shape 25"/>
           <p:cNvSpPr/>
           <p:nvPr/>
         </p:nvSpPr>
@@ -5684,7 +5726,7 @@
       </p:sp>
       <p:sp>
         <p:nvSpPr>
-          <p:cNvPr id="27" name="Text 25"/>
+          <p:cNvPr id="28" name="Text 26"/>
           <p:cNvSpPr/>
           <p:nvPr/>
         </p:nvSpPr>
@@ -5723,7 +5765,7 @@
       </p:sp>
       <p:sp>
         <p:nvSpPr>
-          <p:cNvPr id="28" name="Text 26"/>
+          <p:cNvPr id="29" name="Text 27"/>
           <p:cNvSpPr/>
           <p:nvPr/>
         </p:nvSpPr>
@@ -5762,7 +5804,7 @@
       </p:sp>
       <p:sp>
         <p:nvSpPr>
-          <p:cNvPr id="29" name="Shape 27"/>
+          <p:cNvPr id="30" name="Shape 28"/>
           <p:cNvSpPr/>
           <p:nvPr/>
         </p:nvSpPr>
@@ -5782,7 +5824,7 @@
       </p:sp>
       <p:sp>
         <p:nvSpPr>
-          <p:cNvPr id="30" name="Shape 28"/>
+          <p:cNvPr id="31" name="Shape 29"/>
           <p:cNvSpPr/>
           <p:nvPr/>
         </p:nvSpPr>
@@ -5802,7 +5844,7 @@
       </p:sp>
       <p:sp>
         <p:nvSpPr>
-          <p:cNvPr id="31" name="Text 29"/>
+          <p:cNvPr id="32" name="Text 30"/>
           <p:cNvSpPr/>
           <p:nvPr/>
         </p:nvSpPr>
@@ -5841,7 +5883,7 @@
       </p:sp>
       <p:sp>
         <p:nvSpPr>
-          <p:cNvPr id="32" name="Text 30"/>
+          <p:cNvPr id="33" name="Text 31"/>
           <p:cNvSpPr/>
           <p:nvPr/>
         </p:nvSpPr>

</xml_diff>

<commit_message>
fix: p4 evidence band 51/51 aligned with p6 + canonical (per-currency deterministic)
- label: '7 日付款承諾曝險驗證檢查全數通過' (natural TC of 7-day payment-commitment exposure validation checks passed)
- note: '按幣別確定性原型' (per-currency deterministic prototype); statRow now renders the note field (was declared in spec but never drawn)
- removed all '付款條件'/'信用狀'/'Payment Advisor' wording from spec
- QA: 9 pages 0 out-of-bounds; p4 label/note 0 overlap, footer gap 105pt; p4/p6 share the same per-currency rolling 7-day exposure language
</commit_message>
<xml_diff>
--- a/Paul-Tradecraft-Executive-Capability-Deck.pptx
+++ b/Paul-Tradecraft-Executive-Capability-Deck.pptx
@@ -3384,7 +3384,7 @@
         <p:spPr>
           <a:xfrm>
             <a:off x="914400" y="4732020"/>
-            <a:ext cx="2009394" cy="777240"/>
+            <a:ext cx="2009394" cy="502920"/>
           </a:xfrm>
           <a:prstGeom prst="rect">
             <a:avLst/>
@@ -3419,34 +3419,14 @@
       </p:sp>
       <p:sp>
         <p:nvSpPr>
-          <p:cNvPr id="11" name="Shape 9"/>
-          <p:cNvSpPr/>
-          <p:nvPr/>
-        </p:nvSpPr>
-        <p:spPr>
-          <a:xfrm>
-            <a:off x="3408426" y="3177540"/>
-            <a:ext cx="45720" cy="2468880"/>
-          </a:xfrm>
-          <a:prstGeom prst="rect">
-            <a:avLst/>
-          </a:prstGeom>
-          <a:solidFill>
-            <a:srgbClr val="1D4ED8"/>
-          </a:solidFill>
-          <a:ln/>
-        </p:spPr>
-      </p:sp>
-      <p:sp>
-        <p:nvSpPr>
-          <p:cNvPr id="12" name="Text 10"/>
-          <p:cNvSpPr/>
-          <p:nvPr/>
-        </p:nvSpPr>
-        <p:spPr>
-          <a:xfrm>
-            <a:off x="3728466" y="3451860"/>
-            <a:ext cx="2009394" cy="1005840"/>
+          <p:cNvPr id="11" name="Text 9"/>
+          <p:cNvSpPr/>
+          <p:nvPr/>
+        </p:nvSpPr>
+        <p:spPr>
+          <a:xfrm>
+            <a:off x="914400" y="5234940"/>
+            <a:ext cx="2009394" cy="365760"/>
           </a:xfrm>
           <a:prstGeom prst="rect">
             <a:avLst/>
@@ -3459,17 +3439,79 @@
           <a:lstStyle/>
           <a:p>
             <a:pPr indent="0" marL="0">
-              <a:buNone/>
-            </a:pPr>
-            <a:r>
-              <a:rPr lang="en-US" sz="4200" b="1" dirty="0">
-                <a:solidFill>
-                  <a:srgbClr val="0B1B33"/>
+              <a:lnSpc>
+                <a:spcPct val="115000"/>
+              </a:lnSpc>
+              <a:buNone/>
+            </a:pPr>
+            <a:r>
+              <a:rPr lang="en-US" sz="950" dirty="0">
+                <a:solidFill>
+                  <a:srgbClr val="8A97A8"/>
                 </a:solidFill>
                 <a:latin typeface="Microsoft JhengHei" pitchFamily="34" charset="0"/>
                 <a:ea typeface="Microsoft JhengHei" pitchFamily="34" charset="-122"/>
                 <a:cs typeface="Microsoft JhengHei" pitchFamily="34" charset="-120"/>
               </a:rPr>
+              <a:t>英文提案與跨國溝通</a:t>
+            </a:r>
+            <a:endParaRPr lang="en-US" sz="950" dirty="0"/>
+          </a:p>
+        </p:txBody>
+      </p:sp>
+      <p:sp>
+        <p:nvSpPr>
+          <p:cNvPr id="12" name="Shape 10"/>
+          <p:cNvSpPr/>
+          <p:nvPr/>
+        </p:nvSpPr>
+        <p:spPr>
+          <a:xfrm>
+            <a:off x="3408426" y="3177540"/>
+            <a:ext cx="45720" cy="2468880"/>
+          </a:xfrm>
+          <a:prstGeom prst="rect">
+            <a:avLst/>
+          </a:prstGeom>
+          <a:solidFill>
+            <a:srgbClr val="1D4ED8"/>
+          </a:solidFill>
+          <a:ln/>
+        </p:spPr>
+      </p:sp>
+      <p:sp>
+        <p:nvSpPr>
+          <p:cNvPr id="13" name="Text 11"/>
+          <p:cNvSpPr/>
+          <p:nvPr/>
+        </p:nvSpPr>
+        <p:spPr>
+          <a:xfrm>
+            <a:off x="3728466" y="3451860"/>
+            <a:ext cx="2009394" cy="1005840"/>
+          </a:xfrm>
+          <a:prstGeom prst="rect">
+            <a:avLst/>
+          </a:prstGeom>
+          <a:noFill/>
+          <a:ln/>
+        </p:spPr>
+        <p:txBody>
+          <a:bodyPr wrap="square" rtlCol="0" anchor="t"/>
+          <a:lstStyle/>
+          <a:p>
+            <a:pPr indent="0" marL="0">
+              <a:buNone/>
+            </a:pPr>
+            <a:r>
+              <a:rPr lang="en-US" sz="4200" b="1" dirty="0">
+                <a:solidFill>
+                  <a:srgbClr val="0B1B33"/>
+                </a:solidFill>
+                <a:latin typeface="Microsoft JhengHei" pitchFamily="34" charset="0"/>
+                <a:ea typeface="Microsoft JhengHei" pitchFamily="34" charset="-122"/>
+                <a:cs typeface="Microsoft JhengHei" pitchFamily="34" charset="-120"/>
+              </a:rPr>
               <a:t>15 年</a:t>
             </a:r>
             <a:endParaRPr lang="en-US" sz="4200" dirty="0"/>
@@ -3478,7 +3520,7 @@
       </p:sp>
       <p:sp>
         <p:nvSpPr>
-          <p:cNvPr id="13" name="Shape 11"/>
+          <p:cNvPr id="14" name="Shape 12"/>
           <p:cNvSpPr/>
           <p:nvPr/>
         </p:nvSpPr>
@@ -3498,14 +3540,14 @@
       </p:sp>
       <p:sp>
         <p:nvSpPr>
-          <p:cNvPr id="14" name="Text 12"/>
+          <p:cNvPr id="15" name="Text 13"/>
           <p:cNvSpPr/>
           <p:nvPr/>
         </p:nvSpPr>
         <p:spPr>
           <a:xfrm>
             <a:off x="3728466" y="4732020"/>
-            <a:ext cx="2009394" cy="777240"/>
+            <a:ext cx="2009394" cy="502920"/>
           </a:xfrm>
           <a:prstGeom prst="rect">
             <a:avLst/>
@@ -3540,7 +3582,49 @@
       </p:sp>
       <p:sp>
         <p:nvSpPr>
-          <p:cNvPr id="15" name="Shape 13"/>
+          <p:cNvPr id="16" name="Text 14"/>
+          <p:cNvSpPr/>
+          <p:nvPr/>
+        </p:nvSpPr>
+        <p:spPr>
+          <a:xfrm>
+            <a:off x="3728466" y="5234940"/>
+            <a:ext cx="2009394" cy="365760"/>
+          </a:xfrm>
+          <a:prstGeom prst="rect">
+            <a:avLst/>
+          </a:prstGeom>
+          <a:noFill/>
+          <a:ln/>
+        </p:spPr>
+        <p:txBody>
+          <a:bodyPr wrap="square" rtlCol="0" anchor="t"/>
+          <a:lstStyle/>
+          <a:p>
+            <a:pPr indent="0" marL="0">
+              <a:lnSpc>
+                <a:spcPct val="115000"/>
+              </a:lnSpc>
+              <a:buNone/>
+            </a:pPr>
+            <a:r>
+              <a:rPr lang="en-US" sz="950" dirty="0">
+                <a:solidFill>
+                  <a:srgbClr val="8A97A8"/>
+                </a:solidFill>
+                <a:latin typeface="Microsoft JhengHei" pitchFamily="34" charset="0"/>
+                <a:ea typeface="Microsoft JhengHei" pitchFamily="34" charset="-122"/>
+                <a:cs typeface="Microsoft JhengHei" pitchFamily="34" charset="-120"/>
+              </a:rPr>
+              <a:t>報價、匯率、交期、客戶</a:t>
+            </a:r>
+            <a:endParaRPr lang="en-US" sz="950" dirty="0"/>
+          </a:p>
+        </p:txBody>
+      </p:sp>
+      <p:sp>
+        <p:nvSpPr>
+          <p:cNvPr id="17" name="Shape 15"/>
           <p:cNvSpPr/>
           <p:nvPr/>
         </p:nvSpPr>
@@ -3560,7 +3644,7 @@
       </p:sp>
       <p:sp>
         <p:nvSpPr>
-          <p:cNvPr id="16" name="Text 14"/>
+          <p:cNvPr id="18" name="Text 16"/>
           <p:cNvSpPr/>
           <p:nvPr/>
         </p:nvSpPr>
@@ -3599,7 +3683,7 @@
       </p:sp>
       <p:sp>
         <p:nvSpPr>
-          <p:cNvPr id="17" name="Shape 15"/>
+          <p:cNvPr id="19" name="Shape 17"/>
           <p:cNvSpPr/>
           <p:nvPr/>
         </p:nvSpPr>
@@ -3619,14 +3703,14 @@
       </p:sp>
       <p:sp>
         <p:nvSpPr>
-          <p:cNvPr id="18" name="Text 16"/>
+          <p:cNvPr id="20" name="Text 18"/>
           <p:cNvSpPr/>
           <p:nvPr/>
         </p:nvSpPr>
         <p:spPr>
           <a:xfrm>
             <a:off x="6542532" y="4732020"/>
-            <a:ext cx="2009394" cy="777240"/>
+            <a:ext cx="2009394" cy="502920"/>
           </a:xfrm>
           <a:prstGeom prst="rect">
             <a:avLst/>
@@ -3661,7 +3745,49 @@
       </p:sp>
       <p:sp>
         <p:nvSpPr>
-          <p:cNvPr id="19" name="Shape 17"/>
+          <p:cNvPr id="21" name="Text 19"/>
+          <p:cNvSpPr/>
+          <p:nvPr/>
+        </p:nvSpPr>
+        <p:spPr>
+          <a:xfrm>
+            <a:off x="6542532" y="5234940"/>
+            <a:ext cx="2009394" cy="365760"/>
+          </a:xfrm>
+          <a:prstGeom prst="rect">
+            <a:avLst/>
+          </a:prstGeom>
+          <a:noFill/>
+          <a:ln/>
+        </p:spPr>
+        <p:txBody>
+          <a:bodyPr wrap="square" rtlCol="0" anchor="t"/>
+          <a:lstStyle/>
+          <a:p>
+            <a:pPr indent="0" marL="0">
+              <a:lnSpc>
+                <a:spcPct val="115000"/>
+              </a:lnSpc>
+              <a:buNone/>
+            </a:pPr>
+            <a:r>
+              <a:rPr lang="en-US" sz="950" dirty="0">
+                <a:solidFill>
+                  <a:srgbClr val="8A97A8"/>
+                </a:solidFill>
+                <a:latin typeface="Microsoft JhengHei" pitchFamily="34" charset="0"/>
+                <a:ea typeface="Microsoft JhengHei" pitchFamily="34" charset="-122"/>
+                <a:cs typeface="Microsoft JhengHei" pitchFamily="34" charset="-120"/>
+              </a:rPr>
+              <a:t>Lead-to-Quote 工作流</a:t>
+            </a:r>
+            <a:endParaRPr lang="en-US" sz="950" dirty="0"/>
+          </a:p>
+        </p:txBody>
+      </p:sp>
+      <p:sp>
+        <p:nvSpPr>
+          <p:cNvPr id="22" name="Shape 20"/>
           <p:cNvSpPr/>
           <p:nvPr/>
         </p:nvSpPr>
@@ -3681,7 +3807,7 @@
       </p:sp>
       <p:sp>
         <p:nvSpPr>
-          <p:cNvPr id="20" name="Text 18"/>
+          <p:cNvPr id="23" name="Text 21"/>
           <p:cNvSpPr/>
           <p:nvPr/>
         </p:nvSpPr>
@@ -3720,7 +3846,7 @@
       </p:sp>
       <p:sp>
         <p:nvSpPr>
-          <p:cNvPr id="21" name="Shape 19"/>
+          <p:cNvPr id="24" name="Shape 22"/>
           <p:cNvSpPr/>
           <p:nvPr/>
         </p:nvSpPr>
@@ -3740,14 +3866,14 @@
       </p:sp>
       <p:sp>
         <p:nvSpPr>
-          <p:cNvPr id="22" name="Text 20"/>
+          <p:cNvPr id="25" name="Text 23"/>
           <p:cNvSpPr/>
           <p:nvPr/>
         </p:nvSpPr>
         <p:spPr>
           <a:xfrm>
             <a:off x="9356598" y="4732020"/>
-            <a:ext cx="2009394" cy="777240"/>
+            <a:ext cx="2009394" cy="502920"/>
           </a:xfrm>
           <a:prstGeom prst="rect">
             <a:avLst/>
@@ -3774,7 +3900,7 @@
                 <a:ea typeface="Microsoft JhengHei" pitchFamily="34" charset="-122"/>
                 <a:cs typeface="Microsoft JhengHei" pitchFamily="34" charset="-120"/>
               </a:rPr>
-              <a:t>付款條件驗證案例通過</a:t>
+              <a:t>7 日付款承諾曝險驗證檢查全數通過</a:t>
             </a:r>
             <a:endParaRPr lang="en-US" sz="1250" dirty="0"/>
           </a:p>
@@ -3782,7 +3908,49 @@
       </p:sp>
       <p:sp>
         <p:nvSpPr>
-          <p:cNvPr id="23" name="Shape 21"/>
+          <p:cNvPr id="26" name="Text 24"/>
+          <p:cNvSpPr/>
+          <p:nvPr/>
+        </p:nvSpPr>
+        <p:spPr>
+          <a:xfrm>
+            <a:off x="9356598" y="5234940"/>
+            <a:ext cx="2009394" cy="365760"/>
+          </a:xfrm>
+          <a:prstGeom prst="rect">
+            <a:avLst/>
+          </a:prstGeom>
+          <a:noFill/>
+          <a:ln/>
+        </p:spPr>
+        <p:txBody>
+          <a:bodyPr wrap="square" rtlCol="0" anchor="t"/>
+          <a:lstStyle/>
+          <a:p>
+            <a:pPr indent="0" marL="0">
+              <a:lnSpc>
+                <a:spcPct val="115000"/>
+              </a:lnSpc>
+              <a:buNone/>
+            </a:pPr>
+            <a:r>
+              <a:rPr lang="en-US" sz="950" dirty="0">
+                <a:solidFill>
+                  <a:srgbClr val="8A97A8"/>
+                </a:solidFill>
+                <a:latin typeface="Microsoft JhengHei" pitchFamily="34" charset="0"/>
+                <a:ea typeface="Microsoft JhengHei" pitchFamily="34" charset="-122"/>
+                <a:cs typeface="Microsoft JhengHei" pitchFamily="34" charset="-120"/>
+              </a:rPr>
+              <a:t>按幣別確定性原型</a:t>
+            </a:r>
+            <a:endParaRPr lang="en-US" sz="950" dirty="0"/>
+          </a:p>
+        </p:txBody>
+      </p:sp>
+      <p:sp>
+        <p:nvSpPr>
+          <p:cNvPr id="27" name="Shape 25"/>
           <p:cNvSpPr/>
           <p:nvPr/>
         </p:nvSpPr>
@@ -3802,7 +3970,7 @@
       </p:sp>
       <p:sp>
         <p:nvSpPr>
-          <p:cNvPr id="24" name="Shape 22"/>
+          <p:cNvPr id="28" name="Shape 26"/>
           <p:cNvSpPr/>
           <p:nvPr/>
         </p:nvSpPr>
@@ -3822,7 +3990,7 @@
       </p:sp>
       <p:sp>
         <p:nvSpPr>
-          <p:cNvPr id="25" name="Text 23"/>
+          <p:cNvPr id="29" name="Text 27"/>
           <p:cNvSpPr/>
           <p:nvPr/>
         </p:nvSpPr>
@@ -3861,7 +4029,7 @@
       </p:sp>
       <p:sp>
         <p:nvSpPr>
-          <p:cNvPr id="26" name="Text 24"/>
+          <p:cNvPr id="30" name="Text 28"/>
           <p:cNvSpPr/>
           <p:nvPr/>
         </p:nvSpPr>
@@ -3900,7 +4068,7 @@
       </p:sp>
       <p:sp>
         <p:nvSpPr>
-          <p:cNvPr id="27" name="Shape 25"/>
+          <p:cNvPr id="31" name="Shape 29"/>
           <p:cNvSpPr/>
           <p:nvPr/>
         </p:nvSpPr>
@@ -3920,7 +4088,7 @@
       </p:sp>
       <p:sp>
         <p:nvSpPr>
-          <p:cNvPr id="28" name="Shape 26"/>
+          <p:cNvPr id="32" name="Shape 30"/>
           <p:cNvSpPr/>
           <p:nvPr/>
         </p:nvSpPr>
@@ -3940,7 +4108,7 @@
       </p:sp>
       <p:sp>
         <p:nvSpPr>
-          <p:cNvPr id="29" name="Text 27"/>
+          <p:cNvPr id="33" name="Text 31"/>
           <p:cNvSpPr/>
           <p:nvPr/>
         </p:nvSpPr>
@@ -3979,7 +4147,7 @@
       </p:sp>
       <p:sp>
         <p:nvSpPr>
-          <p:cNvPr id="30" name="Text 28"/>
+          <p:cNvPr id="34" name="Text 32"/>
           <p:cNvSpPr/>
           <p:nvPr/>
         </p:nvSpPr>

</xml_diff>